<commit_message>
Final: Complete Bluestock MF Capstone
</commit_message>
<xml_diff>
--- a/reports/Presentation.pptx
+++ b/reports/Presentation.pptx
@@ -15,6 +15,8 @@
     <p:sldId id="263" r:id="rId14"/>
     <p:sldId id="264" r:id="rId15"/>
     <p:sldId id="265" r:id="rId16"/>
+    <p:sldId id="266" r:id="rId17"/>
+    <p:sldId id="267" r:id="rId18"/>
   </p:sldIdLst>
   <p:sldSz cx="12191695" cy="6858000" type="screen4x3"/>
   <p:notesSz cx="6858000" cy="9144000"/>
@@ -3099,19 +3101,29 @@
       <p:grpSpPr/>
       <p:sp>
         <p:nvSpPr>
-          <p:cNvPr id="2" name="Title 1"/>
-          <p:cNvSpPr>
-            <a:spLocks noGrp="1"/>
-          </p:cNvSpPr>
-          <p:nvPr>
-            <p:ph type="ctrTitle"/>
-          </p:nvPr>
-        </p:nvSpPr>
-        <p:spPr/>
-        <p:txBody>
-          <a:bodyPr/>
-          <a:lstStyle/>
-          <a:p>
+          <p:cNvPr id="2" name="TextBox 1"/>
+          <p:cNvSpPr txBox="1"/>
+          <p:nvPr/>
+        </p:nvSpPr>
+        <p:spPr>
+          <a:xfrm>
+            <a:off x="914400" y="1920240"/>
+            <a:ext cx="10332720" cy="1371600"/>
+          </a:xfrm>
+          <a:prstGeom prst="rect">
+            <a:avLst/>
+          </a:prstGeom>
+          <a:noFill/>
+        </p:spPr>
+        <p:txBody>
+          <a:bodyPr wrap="none">
+            <a:spAutoFit/>
+          </a:bodyPr>
+          <a:lstStyle/>
+          <a:p>
+            <a:pPr algn="l">
+              <a:defRPr sz="3800" b="1"/>
+            </a:pPr>
             <a:r>
               <a:t>Bluestock Mutual Fund Analytics</a:t>
             </a:r>
@@ -3120,26 +3132,35 @@
       </p:sp>
       <p:sp>
         <p:nvSpPr>
-          <p:cNvPr id="3" name="Subtitle 2"/>
-          <p:cNvSpPr>
-            <a:spLocks noGrp="1"/>
-          </p:cNvSpPr>
-          <p:nvPr>
-            <p:ph type="subTitle" idx="1"/>
-          </p:nvPr>
-        </p:nvSpPr>
-        <p:spPr/>
-        <p:txBody>
-          <a:bodyPr/>
-          <a:lstStyle/>
-          <a:p>
+          <p:cNvPr id="3" name="TextBox 2"/>
+          <p:cNvSpPr txBox="1"/>
+          <p:nvPr/>
+        </p:nvSpPr>
+        <p:spPr>
+          <a:xfrm>
+            <a:off x="1097280" y="3383280"/>
+            <a:ext cx="9966960" cy="1097280"/>
+          </a:xfrm>
+          <a:prstGeom prst="rect">
+            <a:avLst/>
+          </a:prstGeom>
+          <a:noFill/>
+        </p:spPr>
+        <p:txBody>
+          <a:bodyPr wrap="none">
+            <a:spAutoFit/>
+          </a:bodyPr>
+          <a:lstStyle/>
+          <a:p>
+            <a:pPr algn="l">
+              <a:defRPr sz="2400"/>
+            </a:pPr>
             <a:r>
               <a:t>Capstone Project</a:t>
             </a:r>
-          </a:p>
-          <a:p>
-            <a:r>
-              <a:t>End-to-end data engineering, analytics and Power BI dashboard</a:t>
+            <a:br/>
+            <a:r>
+              <a:t>Data Engineering • Analytics • Power BI</a:t>
             </a:r>
           </a:p>
         </p:txBody>
@@ -3176,58 +3197,369 @@
         <p:txBody>
           <a:bodyPr/>
           <a:lstStyle/>
-          <a:p>
-            <a:r>
-              <a:t>Conclusion</a:t>
-            </a:r>
-          </a:p>
-        </p:txBody>
-      </p:sp>
-      <p:sp>
-        <p:nvSpPr>
-          <p:cNvPr id="3" name="Content Placeholder 2"/>
-          <p:cNvSpPr>
-            <a:spLocks noGrp="1"/>
-          </p:cNvSpPr>
-          <p:nvPr>
-            <p:ph idx="1"/>
+          <a:p/>
+        </p:txBody>
+      </p:sp>
+      <p:sp>
+        <p:nvSpPr>
+          <p:cNvPr id="3" name="TextBox 2"/>
+          <p:cNvSpPr txBox="1"/>
+          <p:nvPr/>
+        </p:nvSpPr>
+        <p:spPr>
+          <a:xfrm>
+            <a:off x="640080" y="411480"/>
+            <a:ext cx="10881360" cy="640080"/>
+          </a:xfrm>
+          <a:prstGeom prst="rect">
+            <a:avLst/>
+          </a:prstGeom>
+          <a:noFill/>
+        </p:spPr>
+        <p:txBody>
+          <a:bodyPr wrap="none">
+            <a:spAutoFit/>
+          </a:bodyPr>
+          <a:lstStyle/>
+          <a:p>
+            <a:pPr>
+              <a:defRPr sz="3000" b="1"/>
+            </a:pPr>
+            <a:r>
+              <a:t>Dashboard — Investor &amp; Advanced Analytics</a:t>
+            </a:r>
+          </a:p>
+        </p:txBody>
+      </p:sp>
+      <p:sp>
+        <p:nvSpPr>
+          <p:cNvPr id="4" name="TextBox 3"/>
+          <p:cNvSpPr txBox="1"/>
+          <p:nvPr/>
+        </p:nvSpPr>
+        <p:spPr>
+          <a:xfrm>
+            <a:off x="822960" y="1234440"/>
+            <a:ext cx="10515600" cy="5029200"/>
+          </a:xfrm>
+          <a:prstGeom prst="rect">
+            <a:avLst/>
+          </a:prstGeom>
+          <a:noFill/>
+        </p:spPr>
+        <p:txBody>
+          <a:bodyPr wrap="square">
+            <a:spAutoFit/>
+          </a:bodyPr>
+          <a:lstStyle/>
+          <a:p>
+            <a:pPr>
+              <a:spcAft>
+                <a:spcPts val="1200"/>
+              </a:spcAft>
+              <a:defRPr sz="2100"/>
+            </a:pPr>
+            <a:r>
+              <a:t>Page 3: Investor &amp; SIP Analytics</a:t>
+            </a:r>
+          </a:p>
+          <a:p>
+            <a:pPr>
+              <a:spcAft>
+                <a:spcPts val="1200"/>
+              </a:spcAft>
+              <a:defRPr sz="2100"/>
+            </a:pPr>
+            <a:r>
+              <a:t>Page 4: Advanced Analytics</a:t>
+            </a:r>
+          </a:p>
+          <a:p>
+            <a:pPr>
+              <a:spcAft>
+                <a:spcPts val="1200"/>
+              </a:spcAft>
+              <a:defRPr sz="2100"/>
+            </a:pPr>
+            <a:r>
+              <a:t>Includes SIP trends, transaction activity, VaR, cohort retention and recommendation analysis.</a:t>
+            </a:r>
+          </a:p>
+          <a:p>
+            <a:pPr>
+              <a:spcAft>
+                <a:spcPts val="1200"/>
+              </a:spcAft>
+              <a:defRPr sz="2100"/>
+            </a:pPr>
+            <a:r>
+              <a:t>Power BI file: dashboard/bluestock_mf_capstone.pbix</a:t>
+            </a:r>
+          </a:p>
+        </p:txBody>
+      </p:sp>
+    </p:spTree>
+  </p:cSld>
+  <p:clrMapOvr>
+    <a:masterClrMapping/>
+  </p:clrMapOvr>
+</p:sld>
+</file>
+
+<file path=ppt/slides/slide11.xml><?xml version="1.0" encoding="utf-8"?>
+<p:sld xmlns:a="http://schemas.openxmlformats.org/drawingml/2006/main" xmlns:p="http://schemas.openxmlformats.org/presentationml/2006/main" xmlns:r="http://schemas.openxmlformats.org/officeDocument/2006/relationships">
+  <p:cSld>
+    <p:spTree>
+      <p:nvGrpSpPr>
+        <p:cNvPr id="1" name=""/>
+        <p:cNvGrpSpPr/>
+        <p:nvPr/>
+      </p:nvGrpSpPr>
+      <p:grpSpPr/>
+      <p:sp>
+        <p:nvSpPr>
+          <p:cNvPr id="2" name="Title 1"/>
+          <p:cNvSpPr>
+            <a:spLocks noGrp="1"/>
+          </p:cNvSpPr>
+          <p:nvPr>
+            <p:ph type="title"/>
           </p:nvPr>
         </p:nvSpPr>
         <p:spPr/>
         <p:txBody>
           <a:bodyPr/>
           <a:lstStyle/>
-          <a:p>
-            <a:pPr>
-              <a:spcAft>
-                <a:spcPts val="1000"/>
-              </a:spcAft>
-              <a:defRPr sz="2200"/>
-            </a:pPr>
-            <a:r>
-              <a:t>The project converts raw mutual fund data into validated, reproducible analytics.</a:t>
-            </a:r>
-          </a:p>
-          <a:p>
-            <a:pPr>
-              <a:spcAft>
-                <a:spcPts val="1000"/>
-              </a:spcAft>
-              <a:defRPr sz="2200"/>
-            </a:pPr>
-            <a:r>
-              <a:t>Performance, risk, investor retention and recommendation insights are combined in one dashboard.</a:t>
-            </a:r>
-          </a:p>
-          <a:p>
-            <a:pPr>
-              <a:spcAft>
-                <a:spcPts val="1000"/>
-              </a:spcAft>
-              <a:defRPr sz="2200"/>
-            </a:pPr>
-            <a:r>
-              <a:t>The workflow is designed for repeatable analysis and future extension.</a:t>
+          <a:p/>
+        </p:txBody>
+      </p:sp>
+      <p:sp>
+        <p:nvSpPr>
+          <p:cNvPr id="3" name="TextBox 2"/>
+          <p:cNvSpPr txBox="1"/>
+          <p:nvPr/>
+        </p:nvSpPr>
+        <p:spPr>
+          <a:xfrm>
+            <a:off x="640080" y="411480"/>
+            <a:ext cx="10881360" cy="640080"/>
+          </a:xfrm>
+          <a:prstGeom prst="rect">
+            <a:avLst/>
+          </a:prstGeom>
+          <a:noFill/>
+        </p:spPr>
+        <p:txBody>
+          <a:bodyPr wrap="none">
+            <a:spAutoFit/>
+          </a:bodyPr>
+          <a:lstStyle/>
+          <a:p>
+            <a:pPr>
+              <a:defRPr sz="3000" b="1"/>
+            </a:pPr>
+            <a:r>
+              <a:t>Key Findings &amp; Recommendations</a:t>
+            </a:r>
+          </a:p>
+        </p:txBody>
+      </p:sp>
+      <p:sp>
+        <p:nvSpPr>
+          <p:cNvPr id="4" name="TextBox 3"/>
+          <p:cNvSpPr txBox="1"/>
+          <p:nvPr/>
+        </p:nvSpPr>
+        <p:spPr>
+          <a:xfrm>
+            <a:off x="822960" y="1234440"/>
+            <a:ext cx="10515600" cy="5029200"/>
+          </a:xfrm>
+          <a:prstGeom prst="rect">
+            <a:avLst/>
+          </a:prstGeom>
+          <a:noFill/>
+        </p:spPr>
+        <p:txBody>
+          <a:bodyPr wrap="square">
+            <a:spAutoFit/>
+          </a:bodyPr>
+          <a:lstStyle/>
+          <a:p>
+            <a:pPr>
+              <a:spcAft>
+                <a:spcPts val="1200"/>
+              </a:spcAft>
+              <a:defRPr sz="2100"/>
+            </a:pPr>
+            <a:r>
+              <a:t>Use data-quality checks as a standard step before analytics.</a:t>
+            </a:r>
+          </a:p>
+          <a:p>
+            <a:pPr>
+              <a:spcAft>
+                <a:spcPts val="1200"/>
+              </a:spcAft>
+              <a:defRPr sz="2100"/>
+            </a:pPr>
+            <a:r>
+              <a:t>Interpret return together with volatility, drawdown and risk-adjusted measures.</a:t>
+            </a:r>
+          </a:p>
+          <a:p>
+            <a:pPr>
+              <a:spcAft>
+                <a:spcPts val="1200"/>
+              </a:spcAft>
+              <a:defRPr sz="2100"/>
+            </a:pPr>
+            <a:r>
+              <a:t>Use cohort analysis to understand continued transaction activity.</a:t>
+            </a:r>
+          </a:p>
+          <a:p>
+            <a:pPr>
+              <a:spcAft>
+                <a:spcPts val="1200"/>
+              </a:spcAft>
+              <a:defRPr sz="2100"/>
+            </a:pPr>
+            <a:r>
+              <a:t>Treat the recommendation score as an analytical screening tool, not personalized financial advice.</a:t>
+            </a:r>
+          </a:p>
+          <a:p>
+            <a:pPr>
+              <a:spcAft>
+                <a:spcPts val="1200"/>
+              </a:spcAft>
+              <a:defRPr sz="2100"/>
+            </a:pPr>
+            <a:r>
+              <a:t>Future extensions can include scheduled pipelines, Streamlit, Monte Carlo and portfolio optimization.</a:t>
+            </a:r>
+          </a:p>
+        </p:txBody>
+      </p:sp>
+    </p:spTree>
+  </p:cSld>
+  <p:clrMapOvr>
+    <a:masterClrMapping/>
+  </p:clrMapOvr>
+</p:sld>
+</file>
+
+<file path=ppt/slides/slide12.xml><?xml version="1.0" encoding="utf-8"?>
+<p:sld xmlns:a="http://schemas.openxmlformats.org/drawingml/2006/main" xmlns:p="http://schemas.openxmlformats.org/presentationml/2006/main" xmlns:r="http://schemas.openxmlformats.org/officeDocument/2006/relationships">
+  <p:cSld>
+    <p:spTree>
+      <p:nvGrpSpPr>
+        <p:cNvPr id="1" name=""/>
+        <p:cNvGrpSpPr/>
+        <p:nvPr/>
+      </p:nvGrpSpPr>
+      <p:grpSpPr/>
+      <p:sp>
+        <p:nvSpPr>
+          <p:cNvPr id="2" name="Title 1"/>
+          <p:cNvSpPr>
+            <a:spLocks noGrp="1"/>
+          </p:cNvSpPr>
+          <p:nvPr>
+            <p:ph type="title"/>
+          </p:nvPr>
+        </p:nvSpPr>
+        <p:spPr/>
+        <p:txBody>
+          <a:bodyPr/>
+          <a:lstStyle/>
+          <a:p/>
+        </p:txBody>
+      </p:sp>
+      <p:sp>
+        <p:nvSpPr>
+          <p:cNvPr id="3" name="TextBox 2"/>
+          <p:cNvSpPr txBox="1"/>
+          <p:nvPr/>
+        </p:nvSpPr>
+        <p:spPr>
+          <a:xfrm>
+            <a:off x="640080" y="411480"/>
+            <a:ext cx="10881360" cy="640080"/>
+          </a:xfrm>
+          <a:prstGeom prst="rect">
+            <a:avLst/>
+          </a:prstGeom>
+          <a:noFill/>
+        </p:spPr>
+        <p:txBody>
+          <a:bodyPr wrap="none">
+            <a:spAutoFit/>
+          </a:bodyPr>
+          <a:lstStyle/>
+          <a:p>
+            <a:pPr>
+              <a:defRPr sz="3000" b="1"/>
+            </a:pPr>
+            <a:r>
+              <a:t>Thank You</a:t>
+            </a:r>
+          </a:p>
+        </p:txBody>
+      </p:sp>
+      <p:sp>
+        <p:nvSpPr>
+          <p:cNvPr id="4" name="TextBox 3"/>
+          <p:cNvSpPr txBox="1"/>
+          <p:nvPr/>
+        </p:nvSpPr>
+        <p:spPr>
+          <a:xfrm>
+            <a:off x="822960" y="1234440"/>
+            <a:ext cx="10515600" cy="5029200"/>
+          </a:xfrm>
+          <a:prstGeom prst="rect">
+            <a:avLst/>
+          </a:prstGeom>
+          <a:noFill/>
+        </p:spPr>
+        <p:txBody>
+          <a:bodyPr wrap="square">
+            <a:spAutoFit/>
+          </a:bodyPr>
+          <a:lstStyle/>
+          <a:p>
+            <a:pPr>
+              <a:spcAft>
+                <a:spcPts val="1200"/>
+              </a:spcAft>
+              <a:defRPr sz="2100"/>
+            </a:pPr>
+            <a:r>
+              <a:t>Bluestock Mutual Fund Analytics Capstone</a:t>
+            </a:r>
+          </a:p>
+          <a:p>
+            <a:pPr>
+              <a:spcAft>
+                <a:spcPts val="1200"/>
+              </a:spcAft>
+              <a:defRPr sz="2100"/>
+            </a:pPr>
+            <a:r>
+              <a:t>Deliverables: Python notebooks and scripts, SQL, Power BI dashboard, final report and presentation</a:t>
+            </a:r>
+          </a:p>
+          <a:p>
+            <a:pPr>
+              <a:spcAft>
+                <a:spcPts val="1200"/>
+              </a:spcAft>
+              <a:defRPr sz="2100"/>
+            </a:pPr>
+            <a:r>
+              <a:t>GitHub: github.com/farhandev-20/mutual-fund-analytics</a:t>
             </a:r>
           </a:p>
         </p:txBody>
@@ -3264,80 +3596,114 @@
         <p:txBody>
           <a:bodyPr/>
           <a:lstStyle/>
-          <a:p>
-            <a:r>
-              <a:t>Project Objectives</a:t>
-            </a:r>
-          </a:p>
-        </p:txBody>
-      </p:sp>
-      <p:sp>
-        <p:nvSpPr>
-          <p:cNvPr id="3" name="Content Placeholder 2"/>
-          <p:cNvSpPr>
-            <a:spLocks noGrp="1"/>
-          </p:cNvSpPr>
-          <p:nvPr>
-            <p:ph idx="1"/>
-          </p:nvPr>
-        </p:nvSpPr>
-        <p:spPr/>
-        <p:txBody>
-          <a:bodyPr/>
-          <a:lstStyle/>
-          <a:p>
-            <a:pPr>
-              <a:spcAft>
-                <a:spcPts val="1000"/>
-              </a:spcAft>
-              <a:defRPr sz="2200"/>
-            </a:pPr>
-            <a:r>
-              <a:t>Build a reusable ETL pipeline</a:t>
-            </a:r>
-          </a:p>
-          <a:p>
-            <a:pPr>
-              <a:spcAft>
-                <a:spcPts val="1000"/>
-              </a:spcAft>
-              <a:defRPr sz="2200"/>
-            </a:pPr>
-            <a:r>
-              <a:t>Clean and validate mutual fund datasets</a:t>
-            </a:r>
-          </a:p>
-          <a:p>
-            <a:pPr>
-              <a:spcAft>
-                <a:spcPts val="1000"/>
-              </a:spcAft>
-              <a:defRPr sz="2200"/>
-            </a:pPr>
-            <a:r>
-              <a:t>Create a relational SQLite database</a:t>
-            </a:r>
-          </a:p>
-          <a:p>
-            <a:pPr>
-              <a:spcAft>
-                <a:spcPts val="1000"/>
-              </a:spcAft>
-              <a:defRPr sz="2200"/>
-            </a:pPr>
-            <a:r>
-              <a:t>Analyze performance, risk and investor behavior</a:t>
-            </a:r>
-          </a:p>
-          <a:p>
-            <a:pPr>
-              <a:spcAft>
-                <a:spcPts val="1000"/>
-              </a:spcAft>
-              <a:defRPr sz="2200"/>
-            </a:pPr>
-            <a:r>
-              <a:t>Build recommendations and an interactive dashboard</a:t>
+          <a:p/>
+        </p:txBody>
+      </p:sp>
+      <p:sp>
+        <p:nvSpPr>
+          <p:cNvPr id="3" name="TextBox 2"/>
+          <p:cNvSpPr txBox="1"/>
+          <p:nvPr/>
+        </p:nvSpPr>
+        <p:spPr>
+          <a:xfrm>
+            <a:off x="640080" y="411480"/>
+            <a:ext cx="10881360" cy="640080"/>
+          </a:xfrm>
+          <a:prstGeom prst="rect">
+            <a:avLst/>
+          </a:prstGeom>
+          <a:noFill/>
+        </p:spPr>
+        <p:txBody>
+          <a:bodyPr wrap="none">
+            <a:spAutoFit/>
+          </a:bodyPr>
+          <a:lstStyle/>
+          <a:p>
+            <a:pPr>
+              <a:defRPr sz="3000" b="1"/>
+            </a:pPr>
+            <a:r>
+              <a:t>Problem &amp; Objectives</a:t>
+            </a:r>
+          </a:p>
+        </p:txBody>
+      </p:sp>
+      <p:sp>
+        <p:nvSpPr>
+          <p:cNvPr id="4" name="TextBox 3"/>
+          <p:cNvSpPr txBox="1"/>
+          <p:nvPr/>
+        </p:nvSpPr>
+        <p:spPr>
+          <a:xfrm>
+            <a:off x="822960" y="1234440"/>
+            <a:ext cx="10515600" cy="5029200"/>
+          </a:xfrm>
+          <a:prstGeom prst="rect">
+            <a:avLst/>
+          </a:prstGeom>
+          <a:noFill/>
+        </p:spPr>
+        <p:txBody>
+          <a:bodyPr wrap="square">
+            <a:spAutoFit/>
+          </a:bodyPr>
+          <a:lstStyle/>
+          <a:p>
+            <a:pPr>
+              <a:spcAft>
+                <a:spcPts val="1200"/>
+              </a:spcAft>
+              <a:defRPr sz="2100"/>
+            </a:pPr>
+            <a:r>
+              <a:t>Integrate mutual fund, market and investor datasets into one analytical workflow.</a:t>
+            </a:r>
+          </a:p>
+          <a:p>
+            <a:pPr>
+              <a:spcAft>
+                <a:spcPts val="1200"/>
+              </a:spcAft>
+              <a:defRPr sz="2100"/>
+            </a:pPr>
+            <a:r>
+              <a:t>Clean and validate data before analysis.</a:t>
+            </a:r>
+          </a:p>
+          <a:p>
+            <a:pPr>
+              <a:spcAft>
+                <a:spcPts val="1200"/>
+              </a:spcAft>
+              <a:defRPr sz="2100"/>
+            </a:pPr>
+            <a:r>
+              <a:t>Calculate performance and risk metrics with transparent methodology.</a:t>
+            </a:r>
+          </a:p>
+          <a:p>
+            <a:pPr>
+              <a:spcAft>
+                <a:spcPts val="1200"/>
+              </a:spcAft>
+              <a:defRPr sz="2100"/>
+            </a:pPr>
+            <a:r>
+              <a:t>Analyze investor retention and build a rule-based recommendation model.</a:t>
+            </a:r>
+          </a:p>
+          <a:p>
+            <a:pPr>
+              <a:spcAft>
+                <a:spcPts val="1200"/>
+              </a:spcAft>
+              <a:defRPr sz="2100"/>
+            </a:pPr>
+            <a:r>
+              <a:t>Deliver an interactive four-page Power BI dashboard.</a:t>
             </a:r>
           </a:p>
         </p:txBody>
@@ -3374,69 +3740,125 @@
         <p:txBody>
           <a:bodyPr/>
           <a:lstStyle/>
-          <a:p>
-            <a:r>
-              <a:t>Data &amp; ETL Pipeline</a:t>
-            </a:r>
-          </a:p>
-        </p:txBody>
-      </p:sp>
-      <p:sp>
-        <p:nvSpPr>
-          <p:cNvPr id="3" name="Content Placeholder 2"/>
-          <p:cNvSpPr>
-            <a:spLocks noGrp="1"/>
-          </p:cNvSpPr>
-          <p:nvPr>
-            <p:ph idx="1"/>
-          </p:nvPr>
-        </p:nvSpPr>
-        <p:spPr/>
-        <p:txBody>
-          <a:bodyPr/>
-          <a:lstStyle/>
-          <a:p>
-            <a:pPr>
-              <a:spcAft>
-                <a:spcPts val="1000"/>
-              </a:spcAft>
-              <a:defRPr sz="2200"/>
-            </a:pPr>
-            <a:r>
-              <a:t>Multiple CSV datasets covering funds, NAV, AUM, SIP, portfolios, benchmarks and investors</a:t>
-            </a:r>
-          </a:p>
-          <a:p>
-            <a:pPr>
-              <a:spcAft>
-                <a:spcPts val="1000"/>
-              </a:spcAft>
-              <a:defRPr sz="2200"/>
-            </a:pPr>
-            <a:r>
-              <a:t>Dynamic project paths — no machine-specific hard-coded paths</a:t>
-            </a:r>
-          </a:p>
-          <a:p>
-            <a:pPr>
-              <a:spcAft>
-                <a:spcPts val="1000"/>
-              </a:spcAft>
-              <a:defRPr sz="2200"/>
-            </a:pPr>
-            <a:r>
-              <a:t>Duplicate removal, empty-row/column handling and column standardization</a:t>
-            </a:r>
-          </a:p>
-          <a:p>
-            <a:pPr>
-              <a:spcAft>
-                <a:spcPts val="1000"/>
-              </a:spcAft>
-              <a:defRPr sz="2200"/>
-            </a:pPr>
-            <a:r>
-              <a:t>Clean datasets written to data/processed</a:t>
+          <a:p/>
+        </p:txBody>
+      </p:sp>
+      <p:sp>
+        <p:nvSpPr>
+          <p:cNvPr id="3" name="TextBox 2"/>
+          <p:cNvSpPr txBox="1"/>
+          <p:nvPr/>
+        </p:nvSpPr>
+        <p:spPr>
+          <a:xfrm>
+            <a:off x="640080" y="411480"/>
+            <a:ext cx="10881360" cy="640080"/>
+          </a:xfrm>
+          <a:prstGeom prst="rect">
+            <a:avLst/>
+          </a:prstGeom>
+          <a:noFill/>
+        </p:spPr>
+        <p:txBody>
+          <a:bodyPr wrap="none">
+            <a:spAutoFit/>
+          </a:bodyPr>
+          <a:lstStyle/>
+          <a:p>
+            <a:pPr>
+              <a:defRPr sz="3000" b="1"/>
+            </a:pPr>
+            <a:r>
+              <a:t>Data Sources</a:t>
+            </a:r>
+          </a:p>
+        </p:txBody>
+      </p:sp>
+      <p:sp>
+        <p:nvSpPr>
+          <p:cNvPr id="4" name="TextBox 3"/>
+          <p:cNvSpPr txBox="1"/>
+          <p:nvPr/>
+        </p:nvSpPr>
+        <p:spPr>
+          <a:xfrm>
+            <a:off x="822960" y="1234440"/>
+            <a:ext cx="10515600" cy="5029200"/>
+          </a:xfrm>
+          <a:prstGeom prst="rect">
+            <a:avLst/>
+          </a:prstGeom>
+          <a:noFill/>
+        </p:spPr>
+        <p:txBody>
+          <a:bodyPr wrap="square">
+            <a:spAutoFit/>
+          </a:bodyPr>
+          <a:lstStyle/>
+          <a:p>
+            <a:pPr>
+              <a:spcAft>
+                <a:spcPts val="1200"/>
+              </a:spcAft>
+              <a:defRPr sz="2100"/>
+            </a:pPr>
+            <a:r>
+              <a:t>Fund master and scheme performance</a:t>
+            </a:r>
+          </a:p>
+          <a:p>
+            <a:pPr>
+              <a:spcAft>
+                <a:spcPts val="1200"/>
+              </a:spcAft>
+              <a:defRPr sz="2100"/>
+            </a:pPr>
+            <a:r>
+              <a:t>Historical NAV and benchmark indices</a:t>
+            </a:r>
+          </a:p>
+          <a:p>
+            <a:pPr>
+              <a:spcAft>
+                <a:spcPts val="1200"/>
+              </a:spcAft>
+              <a:defRPr sz="2100"/>
+            </a:pPr>
+            <a:r>
+              <a:t>AUM by fund house and SIP inflows</a:t>
+            </a:r>
+          </a:p>
+          <a:p>
+            <a:pPr>
+              <a:spcAft>
+                <a:spcPts val="1200"/>
+              </a:spcAft>
+              <a:defRPr sz="2100"/>
+            </a:pPr>
+            <a:r>
+              <a:t>Category inflows and industry folio counts</a:t>
+            </a:r>
+          </a:p>
+          <a:p>
+            <a:pPr>
+              <a:spcAft>
+                <a:spcPts val="1200"/>
+              </a:spcAft>
+              <a:defRPr sz="2100"/>
+            </a:pPr>
+            <a:r>
+              <a:t>Portfolio holdings and investor transactions</a:t>
+            </a:r>
+          </a:p>
+          <a:p>
+            <a:pPr>
+              <a:spcAft>
+                <a:spcPts val="1200"/>
+              </a:spcAft>
+              <a:defRPr sz="2100"/>
+            </a:pPr>
+            <a:r>
+              <a:t>Selected live NAV data fetched through MFAPI</a:t>
             </a:r>
           </a:p>
         </p:txBody>
@@ -3473,69 +3895,125 @@
         <p:txBody>
           <a:bodyPr/>
           <a:lstStyle/>
-          <a:p>
-            <a:r>
-              <a:t>SQLite Database</a:t>
-            </a:r>
-          </a:p>
-        </p:txBody>
-      </p:sp>
-      <p:sp>
-        <p:nvSpPr>
-          <p:cNvPr id="3" name="Content Placeholder 2"/>
-          <p:cNvSpPr>
-            <a:spLocks noGrp="1"/>
-          </p:cNvSpPr>
-          <p:nvPr>
-            <p:ph idx="1"/>
-          </p:nvPr>
-        </p:nvSpPr>
-        <p:spPr/>
-        <p:txBody>
-          <a:bodyPr/>
-          <a:lstStyle/>
-          <a:p>
-            <a:pPr>
-              <a:spcAft>
-                <a:spcPts val="1000"/>
-              </a:spcAft>
-              <a:defRPr sz="2200"/>
-            </a:pPr>
-            <a:r>
-              <a:t>Relational SQLite schema for all major analytical datasets</a:t>
-            </a:r>
-          </a:p>
-          <a:p>
-            <a:pPr>
-              <a:spcAft>
-                <a:spcPts val="1000"/>
-              </a:spcAft>
-              <a:defRPr sz="2200"/>
-            </a:pPr>
-            <a:r>
-              <a:t>Fund master used as the reference table</a:t>
-            </a:r>
-          </a:p>
-          <a:p>
-            <a:pPr>
-              <a:spcAft>
-                <a:spcPts val="1000"/>
-              </a:spcAft>
-              <a:defRPr sz="2200"/>
-            </a:pPr>
-            <a:r>
-              <a:t>Foreign keys maintain AMFI-code integrity</a:t>
-            </a:r>
-          </a:p>
-          <a:p>
-            <a:pPr>
-              <a:spcAft>
-                <a:spcPts val="1000"/>
-              </a:spcAft>
-              <a:defRPr sz="2200"/>
-            </a:pPr>
-            <a:r>
-              <a:t>Database files kept local and excluded from Git</a:t>
+          <a:p/>
+        </p:txBody>
+      </p:sp>
+      <p:sp>
+        <p:nvSpPr>
+          <p:cNvPr id="3" name="TextBox 2"/>
+          <p:cNvSpPr txBox="1"/>
+          <p:nvPr/>
+        </p:nvSpPr>
+        <p:spPr>
+          <a:xfrm>
+            <a:off x="640080" y="411480"/>
+            <a:ext cx="10881360" cy="640080"/>
+          </a:xfrm>
+          <a:prstGeom prst="rect">
+            <a:avLst/>
+          </a:prstGeom>
+          <a:noFill/>
+        </p:spPr>
+        <p:txBody>
+          <a:bodyPr wrap="none">
+            <a:spAutoFit/>
+          </a:bodyPr>
+          <a:lstStyle/>
+          <a:p>
+            <a:pPr>
+              <a:defRPr sz="3000" b="1"/>
+            </a:pPr>
+            <a:r>
+              <a:t>Architecture &amp; ETL</a:t>
+            </a:r>
+          </a:p>
+        </p:txBody>
+      </p:sp>
+      <p:sp>
+        <p:nvSpPr>
+          <p:cNvPr id="4" name="TextBox 3"/>
+          <p:cNvSpPr txBox="1"/>
+          <p:nvPr/>
+        </p:nvSpPr>
+        <p:spPr>
+          <a:xfrm>
+            <a:off x="822960" y="1234440"/>
+            <a:ext cx="10515600" cy="5029200"/>
+          </a:xfrm>
+          <a:prstGeom prst="rect">
+            <a:avLst/>
+          </a:prstGeom>
+          <a:noFill/>
+        </p:spPr>
+        <p:txBody>
+          <a:bodyPr wrap="square">
+            <a:spAutoFit/>
+          </a:bodyPr>
+          <a:lstStyle/>
+          <a:p>
+            <a:pPr>
+              <a:spcAft>
+                <a:spcPts val="1200"/>
+              </a:spcAft>
+              <a:defRPr sz="2100"/>
+            </a:pPr>
+            <a:r>
+              <a:t>Raw CSV files → data/raw</a:t>
+            </a:r>
+          </a:p>
+          <a:p>
+            <a:pPr>
+              <a:spcAft>
+                <a:spcPts val="1200"/>
+              </a:spcAft>
+              <a:defRPr sz="2100"/>
+            </a:pPr>
+            <a:r>
+              <a:t>ETL cleaning → data/processed</a:t>
+            </a:r>
+          </a:p>
+          <a:p>
+            <a:pPr>
+              <a:spcAft>
+                <a:spcPts val="1200"/>
+              </a:spcAft>
+              <a:defRPr sz="2100"/>
+            </a:pPr>
+            <a:r>
+              <a:t>SQLite schema → data/db</a:t>
+            </a:r>
+          </a:p>
+          <a:p>
+            <a:pPr>
+              <a:spcAft>
+                <a:spcPts val="1200"/>
+              </a:spcAft>
+              <a:defRPr sz="2100"/>
+            </a:pPr>
+            <a:r>
+              <a:t>Analytics scripts → metrics, VaR, recommendations</a:t>
+            </a:r>
+          </a:p>
+          <a:p>
+            <a:pPr>
+              <a:spcAft>
+                <a:spcPts val="1200"/>
+              </a:spcAft>
+              <a:defRPr sz="2100"/>
+            </a:pPr>
+            <a:r>
+              <a:t>Power BI → interactive reporting</a:t>
+            </a:r>
+          </a:p>
+          <a:p>
+            <a:pPr>
+              <a:spcAft>
+                <a:spcPts val="1200"/>
+              </a:spcAft>
+              <a:defRPr sz="2100"/>
+            </a:pPr>
+            <a:r>
+              <a:t>run_pipeline.py orchestrates the main Python workflow</a:t>
             </a:r>
           </a:p>
         </p:txBody>
@@ -3572,33 +4050,67 @@
         <p:txBody>
           <a:bodyPr/>
           <a:lstStyle/>
-          <a:p>
-            <a:r>
-              <a:t>Exploratory Data Analysis</a:t>
-            </a:r>
-          </a:p>
-        </p:txBody>
-      </p:sp>
-      <p:sp>
-        <p:nvSpPr>
-          <p:cNvPr id="3" name="Content Placeholder 2"/>
-          <p:cNvSpPr>
-            <a:spLocks noGrp="1"/>
-          </p:cNvSpPr>
-          <p:nvPr>
-            <p:ph idx="1"/>
-          </p:nvPr>
-        </p:nvSpPr>
-        <p:spPr/>
-        <p:txBody>
-          <a:bodyPr/>
-          <a:lstStyle/>
-          <a:p>
-            <a:pPr>
-              <a:spcAft>
-                <a:spcPts val="1000"/>
-              </a:spcAft>
-              <a:defRPr sz="2200"/>
+          <a:p/>
+        </p:txBody>
+      </p:sp>
+      <p:sp>
+        <p:nvSpPr>
+          <p:cNvPr id="3" name="TextBox 2"/>
+          <p:cNvSpPr txBox="1"/>
+          <p:nvPr/>
+        </p:nvSpPr>
+        <p:spPr>
+          <a:xfrm>
+            <a:off x="640080" y="411480"/>
+            <a:ext cx="10881360" cy="640080"/>
+          </a:xfrm>
+          <a:prstGeom prst="rect">
+            <a:avLst/>
+          </a:prstGeom>
+          <a:noFill/>
+        </p:spPr>
+        <p:txBody>
+          <a:bodyPr wrap="none">
+            <a:spAutoFit/>
+          </a:bodyPr>
+          <a:lstStyle/>
+          <a:p>
+            <a:pPr>
+              <a:defRPr sz="3000" b="1"/>
+            </a:pPr>
+            <a:r>
+              <a:t>EDA Highlights — Market &amp; Fund View</a:t>
+            </a:r>
+          </a:p>
+        </p:txBody>
+      </p:sp>
+      <p:sp>
+        <p:nvSpPr>
+          <p:cNvPr id="4" name="TextBox 3"/>
+          <p:cNvSpPr txBox="1"/>
+          <p:nvPr/>
+        </p:nvSpPr>
+        <p:spPr>
+          <a:xfrm>
+            <a:off x="822960" y="1234440"/>
+            <a:ext cx="10515600" cy="5029200"/>
+          </a:xfrm>
+          <a:prstGeom prst="rect">
+            <a:avLst/>
+          </a:prstGeom>
+          <a:noFill/>
+        </p:spPr>
+        <p:txBody>
+          <a:bodyPr wrap="square">
+            <a:spAutoFit/>
+          </a:bodyPr>
+          <a:lstStyle/>
+          <a:p>
+            <a:pPr>
+              <a:spcAft>
+                <a:spcPts val="1200"/>
+              </a:spcAft>
+              <a:defRPr sz="2100"/>
             </a:pPr>
             <a:r>
               <a:t>Fund-house AUM comparison</a:t>
@@ -3607,45 +4119,56 @@
           <a:p>
             <a:pPr>
               <a:spcAft>
-                <a:spcPts val="1000"/>
-              </a:spcAft>
-              <a:defRPr sz="2200"/>
-            </a:pPr>
-            <a:r>
-              <a:t>Monthly SIP inflow trends</a:t>
-            </a:r>
-          </a:p>
-          <a:p>
-            <a:pPr>
-              <a:spcAft>
-                <a:spcPts val="1000"/>
-              </a:spcAft>
-              <a:defRPr sz="2200"/>
-            </a:pPr>
-            <a:r>
-              <a:t>Category-level inflow analysis</a:t>
-            </a:r>
-          </a:p>
-          <a:p>
-            <a:pPr>
-              <a:spcAft>
-                <a:spcPts val="1000"/>
-              </a:spcAft>
-              <a:defRPr sz="2200"/>
-            </a:pPr>
-            <a:r>
-              <a:t>Top scheme performance and NAV trends</a:t>
-            </a:r>
-          </a:p>
-          <a:p>
-            <a:pPr>
-              <a:spcAft>
-                <a:spcPts val="1000"/>
-              </a:spcAft>
-              <a:defRPr sz="2200"/>
-            </a:pPr>
-            <a:r>
-              <a:t>Correlation analysis across key metrics</a:t>
+                <a:spcPts val="1200"/>
+              </a:spcAft>
+              <a:defRPr sz="2100"/>
+            </a:pPr>
+            <a:r>
+              <a:t>SIP inflow trend analysis</a:t>
+            </a:r>
+          </a:p>
+          <a:p>
+            <a:pPr>
+              <a:spcAft>
+                <a:spcPts val="1200"/>
+              </a:spcAft>
+              <a:defRPr sz="2100"/>
+            </a:pPr>
+            <a:r>
+              <a:t>Category-level net inflow analysis</a:t>
+            </a:r>
+          </a:p>
+          <a:p>
+            <a:pPr>
+              <a:spcAft>
+                <a:spcPts val="1200"/>
+              </a:spcAft>
+              <a:defRPr sz="2100"/>
+            </a:pPr>
+            <a:r>
+              <a:t>Scheme 3-year return comparison</a:t>
+            </a:r>
+          </a:p>
+          <a:p>
+            <a:pPr>
+              <a:spcAft>
+                <a:spcPts val="1200"/>
+              </a:spcAft>
+              <a:defRPr sz="2100"/>
+            </a:pPr>
+            <a:r>
+              <a:t>NAV time-series exploration</a:t>
+            </a:r>
+          </a:p>
+          <a:p>
+            <a:pPr>
+              <a:spcAft>
+                <a:spcPts val="1200"/>
+              </a:spcAft>
+              <a:defRPr sz="2100"/>
+            </a:pPr>
+            <a:r>
+              <a:t>Correlation analysis across key variables</a:t>
             </a:r>
           </a:p>
         </p:txBody>
@@ -3682,91 +4205,114 @@
         <p:txBody>
           <a:bodyPr/>
           <a:lstStyle/>
-          <a:p>
-            <a:r>
-              <a:t>Performance &amp; Risk Analytics</a:t>
-            </a:r>
-          </a:p>
-        </p:txBody>
-      </p:sp>
-      <p:sp>
-        <p:nvSpPr>
-          <p:cNvPr id="3" name="Content Placeholder 2"/>
-          <p:cNvSpPr>
-            <a:spLocks noGrp="1"/>
-          </p:cNvSpPr>
-          <p:nvPr>
-            <p:ph idx="1"/>
-          </p:nvPr>
-        </p:nvSpPr>
-        <p:spPr/>
-        <p:txBody>
-          <a:bodyPr/>
-          <a:lstStyle/>
-          <a:p>
-            <a:pPr>
-              <a:spcAft>
-                <a:spcPts val="1000"/>
-              </a:spcAft>
-              <a:defRPr sz="2200"/>
-            </a:pPr>
-            <a:r>
-              <a:t>CAGR based on actual elapsed years</a:t>
-            </a:r>
-          </a:p>
-          <a:p>
-            <a:pPr>
-              <a:spcAft>
-                <a:spcPts val="1000"/>
-              </a:spcAft>
-              <a:defRPr sz="2200"/>
-            </a:pPr>
-            <a:r>
-              <a:t>Annualized volatility</a:t>
-            </a:r>
-          </a:p>
-          <a:p>
-            <a:pPr>
-              <a:spcAft>
-                <a:spcPts val="1000"/>
-              </a:spcAft>
-              <a:defRPr sz="2200"/>
-            </a:pPr>
-            <a:r>
-              <a:t>Maximum drawdown</a:t>
-            </a:r>
-          </a:p>
-          <a:p>
-            <a:pPr>
-              <a:spcAft>
-                <a:spcPts val="1000"/>
-              </a:spcAft>
-              <a:defRPr sz="2200"/>
-            </a:pPr>
-            <a:r>
-              <a:t>Historical 95% daily VaR</a:t>
-            </a:r>
-          </a:p>
-          <a:p>
-            <a:pPr>
-              <a:spcAft>
-                <a:spcPts val="1000"/>
-              </a:spcAft>
-              <a:defRPr sz="2200"/>
-            </a:pPr>
-            <a:r>
-              <a:t>Beta against benchmark</a:t>
-            </a:r>
-          </a:p>
-          <a:p>
-            <a:pPr>
-              <a:spcAft>
-                <a:spcPts val="1000"/>
-              </a:spcAft>
-              <a:defRPr sz="2200"/>
-            </a:pPr>
-            <a:r>
-              <a:t>Sharpe ratio with explicit zero risk-free-rate assumption</a:t>
+          <a:p/>
+        </p:txBody>
+      </p:sp>
+      <p:sp>
+        <p:nvSpPr>
+          <p:cNvPr id="3" name="TextBox 2"/>
+          <p:cNvSpPr txBox="1"/>
+          <p:nvPr/>
+        </p:nvSpPr>
+        <p:spPr>
+          <a:xfrm>
+            <a:off x="640080" y="411480"/>
+            <a:ext cx="10881360" cy="640080"/>
+          </a:xfrm>
+          <a:prstGeom prst="rect">
+            <a:avLst/>
+          </a:prstGeom>
+          <a:noFill/>
+        </p:spPr>
+        <p:txBody>
+          <a:bodyPr wrap="none">
+            <a:spAutoFit/>
+          </a:bodyPr>
+          <a:lstStyle/>
+          <a:p>
+            <a:pPr>
+              <a:defRPr sz="3000" b="1"/>
+            </a:pPr>
+            <a:r>
+              <a:t>EDA Highlights — Investor View</a:t>
+            </a:r>
+          </a:p>
+        </p:txBody>
+      </p:sp>
+      <p:sp>
+        <p:nvSpPr>
+          <p:cNvPr id="4" name="TextBox 3"/>
+          <p:cNvSpPr txBox="1"/>
+          <p:nvPr/>
+        </p:nvSpPr>
+        <p:spPr>
+          <a:xfrm>
+            <a:off x="822960" y="1234440"/>
+            <a:ext cx="10515600" cy="5029200"/>
+          </a:xfrm>
+          <a:prstGeom prst="rect">
+            <a:avLst/>
+          </a:prstGeom>
+          <a:noFill/>
+        </p:spPr>
+        <p:txBody>
+          <a:bodyPr wrap="square">
+            <a:spAutoFit/>
+          </a:bodyPr>
+          <a:lstStyle/>
+          <a:p>
+            <a:pPr>
+              <a:spcAft>
+                <a:spcPts val="1200"/>
+              </a:spcAft>
+              <a:defRPr sz="2100"/>
+            </a:pPr>
+            <a:r>
+              <a:t>Transaction activity by type</a:t>
+            </a:r>
+          </a:p>
+          <a:p>
+            <a:pPr>
+              <a:spcAft>
+                <a:spcPts val="1200"/>
+              </a:spcAft>
+              <a:defRPr sz="2100"/>
+            </a:pPr>
+            <a:r>
+              <a:t>Investor distribution by state and city tier</a:t>
+            </a:r>
+          </a:p>
+          <a:p>
+            <a:pPr>
+              <a:spcAft>
+                <a:spcPts val="1200"/>
+              </a:spcAft>
+              <a:defRPr sz="2100"/>
+            </a:pPr>
+            <a:r>
+              <a:t>SIP activity and YoY growth</a:t>
+            </a:r>
+          </a:p>
+          <a:p>
+            <a:pPr>
+              <a:spcAft>
+                <a:spcPts val="1200"/>
+              </a:spcAft>
+              <a:defRPr sz="2100"/>
+            </a:pPr>
+            <a:r>
+              <a:t>Cohort formation based on first transaction month</a:t>
+            </a:r>
+          </a:p>
+          <a:p>
+            <a:pPr>
+              <a:spcAft>
+                <a:spcPts val="1200"/>
+              </a:spcAft>
+              <a:defRPr sz="2100"/>
+            </a:pPr>
+            <a:r>
+              <a:t>Retention measured across months since cohort entry</a:t>
             </a:r>
           </a:p>
         </p:txBody>
@@ -3803,69 +4349,103 @@
         <p:txBody>
           <a:bodyPr/>
           <a:lstStyle/>
-          <a:p>
-            <a:r>
-              <a:t>Advanced Analytics</a:t>
-            </a:r>
-          </a:p>
-        </p:txBody>
-      </p:sp>
-      <p:sp>
-        <p:nvSpPr>
-          <p:cNvPr id="3" name="Content Placeholder 2"/>
-          <p:cNvSpPr>
-            <a:spLocks noGrp="1"/>
-          </p:cNvSpPr>
-          <p:nvPr>
-            <p:ph idx="1"/>
-          </p:nvPr>
-        </p:nvSpPr>
-        <p:spPr/>
-        <p:txBody>
-          <a:bodyPr/>
-          <a:lstStyle/>
-          <a:p>
-            <a:pPr>
-              <a:spcAft>
-                <a:spcPts val="1000"/>
-              </a:spcAft>
-              <a:defRPr sz="2200"/>
-            </a:pPr>
-            <a:r>
-              <a:t>Investor cohort retention by first transaction month</a:t>
-            </a:r>
-          </a:p>
-          <a:p>
-            <a:pPr>
-              <a:spcAft>
-                <a:spcPts val="1000"/>
-              </a:spcAft>
-              <a:defRPr sz="2200"/>
-            </a:pPr>
-            <a:r>
-              <a:t>Historical VaR visualization</a:t>
-            </a:r>
-          </a:p>
-          <a:p>
-            <a:pPr>
-              <a:spcAft>
-                <a:spcPts val="1000"/>
-              </a:spcAft>
-              <a:defRPr sz="2200"/>
-            </a:pPr>
-            <a:r>
-              <a:t>Rule-based recommendation score</a:t>
-            </a:r>
-          </a:p>
-          <a:p>
-            <a:pPr>
-              <a:spcAft>
-                <a:spcPts val="1000"/>
-              </a:spcAft>
-              <a:defRPr sz="2200"/>
-            </a:pPr>
-            <a:r>
-              <a:t>Recommendation weights: Return 30%, Sharpe 25%, Volatility 20%, Drawdown 15%, Expense 10%</a:t>
+          <a:p/>
+        </p:txBody>
+      </p:sp>
+      <p:sp>
+        <p:nvSpPr>
+          <p:cNvPr id="3" name="TextBox 2"/>
+          <p:cNvSpPr txBox="1"/>
+          <p:nvPr/>
+        </p:nvSpPr>
+        <p:spPr>
+          <a:xfrm>
+            <a:off x="640080" y="411480"/>
+            <a:ext cx="10881360" cy="640080"/>
+          </a:xfrm>
+          <a:prstGeom prst="rect">
+            <a:avLst/>
+          </a:prstGeom>
+          <a:noFill/>
+        </p:spPr>
+        <p:txBody>
+          <a:bodyPr wrap="none">
+            <a:spAutoFit/>
+          </a:bodyPr>
+          <a:lstStyle/>
+          <a:p>
+            <a:pPr>
+              <a:defRPr sz="3000" b="1"/>
+            </a:pPr>
+            <a:r>
+              <a:t>Performance Metrics — Return</a:t>
+            </a:r>
+          </a:p>
+        </p:txBody>
+      </p:sp>
+      <p:sp>
+        <p:nvSpPr>
+          <p:cNvPr id="4" name="TextBox 3"/>
+          <p:cNvSpPr txBox="1"/>
+          <p:nvPr/>
+        </p:nvSpPr>
+        <p:spPr>
+          <a:xfrm>
+            <a:off x="822960" y="1234440"/>
+            <a:ext cx="10515600" cy="5029200"/>
+          </a:xfrm>
+          <a:prstGeom prst="rect">
+            <a:avLst/>
+          </a:prstGeom>
+          <a:noFill/>
+        </p:spPr>
+        <p:txBody>
+          <a:bodyPr wrap="square">
+            <a:spAutoFit/>
+          </a:bodyPr>
+          <a:lstStyle/>
+          <a:p>
+            <a:pPr>
+              <a:spcAft>
+                <a:spcPts val="1200"/>
+              </a:spcAft>
+              <a:defRPr sz="2100"/>
+            </a:pPr>
+            <a:r>
+              <a:t>CAGR uses actual elapsed years between observations.</a:t>
+            </a:r>
+          </a:p>
+          <a:p>
+            <a:pPr>
+              <a:spcAft>
+                <a:spcPts val="1200"/>
+              </a:spcAft>
+              <a:defRPr sz="2100"/>
+            </a:pPr>
+            <a:r>
+              <a:t>1-year, 3-year and 5-year returns are available in the supplied performance data.</a:t>
+            </a:r>
+          </a:p>
+          <a:p>
+            <a:pPr>
+              <a:spcAft>
+                <a:spcPts val="1200"/>
+              </a:spcAft>
+              <a:defRPr sz="2100"/>
+            </a:pPr>
+            <a:r>
+              <a:t>Annualized volatility is calculated from daily returns using √252.</a:t>
+            </a:r>
+          </a:p>
+          <a:p>
+            <a:pPr>
+              <a:spcAft>
+                <a:spcPts val="1200"/>
+              </a:spcAft>
+              <a:defRPr sz="2100"/>
+            </a:pPr>
+            <a:r>
+              <a:t>Maximum drawdown captures the largest peak-to-trough decline.</a:t>
             </a:r>
           </a:p>
         </p:txBody>
@@ -3902,80 +4482,103 @@
         <p:txBody>
           <a:bodyPr/>
           <a:lstStyle/>
-          <a:p>
-            <a:r>
-              <a:t>Power BI Dashboard</a:t>
-            </a:r>
-          </a:p>
-        </p:txBody>
-      </p:sp>
-      <p:sp>
-        <p:nvSpPr>
-          <p:cNvPr id="3" name="Content Placeholder 2"/>
-          <p:cNvSpPr>
-            <a:spLocks noGrp="1"/>
-          </p:cNvSpPr>
-          <p:nvPr>
-            <p:ph idx="1"/>
-          </p:nvPr>
-        </p:nvSpPr>
-        <p:spPr/>
-        <p:txBody>
-          <a:bodyPr/>
-          <a:lstStyle/>
-          <a:p>
-            <a:pPr>
-              <a:spcAft>
-                <a:spcPts val="1000"/>
-              </a:spcAft>
-              <a:defRPr sz="2200"/>
-            </a:pPr>
-            <a:r>
-              <a:t>Page 1 — Executive Overview</a:t>
-            </a:r>
-          </a:p>
-          <a:p>
-            <a:pPr>
-              <a:spcAft>
-                <a:spcPts val="1000"/>
-              </a:spcAft>
-              <a:defRPr sz="2200"/>
-            </a:pPr>
-            <a:r>
-              <a:t>Page 2 — Fund Performance &amp; Risk</a:t>
-            </a:r>
-          </a:p>
-          <a:p>
-            <a:pPr>
-              <a:spcAft>
-                <a:spcPts val="1000"/>
-              </a:spcAft>
-              <a:defRPr sz="2200"/>
-            </a:pPr>
-            <a:r>
-              <a:t>Page 3 — Investor &amp; SIP Analytics</a:t>
-            </a:r>
-          </a:p>
-          <a:p>
-            <a:pPr>
-              <a:spcAft>
-                <a:spcPts val="1000"/>
-              </a:spcAft>
-              <a:defRPr sz="2200"/>
-            </a:pPr>
-            <a:r>
-              <a:t>Page 4 — Advanced Analytics</a:t>
-            </a:r>
-          </a:p>
-          <a:p>
-            <a:pPr>
-              <a:spcAft>
-                <a:spcPts val="1000"/>
-              </a:spcAft>
-              <a:defRPr sz="2200"/>
-            </a:pPr>
-            <a:r>
-              <a:t>Interactive slicers support business-focused exploration</a:t>
+          <a:p/>
+        </p:txBody>
+      </p:sp>
+      <p:sp>
+        <p:nvSpPr>
+          <p:cNvPr id="3" name="TextBox 2"/>
+          <p:cNvSpPr txBox="1"/>
+          <p:nvPr/>
+        </p:nvSpPr>
+        <p:spPr>
+          <a:xfrm>
+            <a:off x="640080" y="411480"/>
+            <a:ext cx="10881360" cy="640080"/>
+          </a:xfrm>
+          <a:prstGeom prst="rect">
+            <a:avLst/>
+          </a:prstGeom>
+          <a:noFill/>
+        </p:spPr>
+        <p:txBody>
+          <a:bodyPr wrap="none">
+            <a:spAutoFit/>
+          </a:bodyPr>
+          <a:lstStyle/>
+          <a:p>
+            <a:pPr>
+              <a:defRPr sz="3000" b="1"/>
+            </a:pPr>
+            <a:r>
+              <a:t>Performance Metrics — Risk</a:t>
+            </a:r>
+          </a:p>
+        </p:txBody>
+      </p:sp>
+      <p:sp>
+        <p:nvSpPr>
+          <p:cNvPr id="4" name="TextBox 3"/>
+          <p:cNvSpPr txBox="1"/>
+          <p:nvPr/>
+        </p:nvSpPr>
+        <p:spPr>
+          <a:xfrm>
+            <a:off x="822960" y="1234440"/>
+            <a:ext cx="10515600" cy="5029200"/>
+          </a:xfrm>
+          <a:prstGeom prst="rect">
+            <a:avLst/>
+          </a:prstGeom>
+          <a:noFill/>
+        </p:spPr>
+        <p:txBody>
+          <a:bodyPr wrap="square">
+            <a:spAutoFit/>
+          </a:bodyPr>
+          <a:lstStyle/>
+          <a:p>
+            <a:pPr>
+              <a:spcAft>
+                <a:spcPts val="1200"/>
+              </a:spcAft>
+              <a:defRPr sz="2100"/>
+            </a:pPr>
+            <a:r>
+              <a:t>Historical 95% daily VaR uses the empirical 5th percentile of daily returns.</a:t>
+            </a:r>
+          </a:p>
+          <a:p>
+            <a:pPr>
+              <a:spcAft>
+                <a:spcPts val="1200"/>
+              </a:spcAft>
+              <a:defRPr sz="2100"/>
+            </a:pPr>
+            <a:r>
+              <a:t>Beta is calculated against an aligned NIFTY100 benchmark when available.</a:t>
+            </a:r>
+          </a:p>
+          <a:p>
+            <a:pPr>
+              <a:spcAft>
+                <a:spcPts val="1200"/>
+              </a:spcAft>
+              <a:defRPr sz="2100"/>
+            </a:pPr>
+            <a:r>
+              <a:t>Sharpe ratio is annualized from daily returns.</a:t>
+            </a:r>
+          </a:p>
+          <a:p>
+            <a:pPr>
+              <a:spcAft>
+                <a:spcPts val="1200"/>
+              </a:spcAft>
+              <a:defRPr sz="2100"/>
+            </a:pPr>
+            <a:r>
+              <a:t>Zero risk-free rate is assumed because no risk-free series was supplied.</a:t>
             </a:r>
           </a:p>
         </p:txBody>
@@ -4012,80 +4615,103 @@
         <p:txBody>
           <a:bodyPr/>
           <a:lstStyle/>
-          <a:p>
-            <a:r>
-              <a:t>Key Deliverables</a:t>
-            </a:r>
-          </a:p>
-        </p:txBody>
-      </p:sp>
-      <p:sp>
-        <p:nvSpPr>
-          <p:cNvPr id="3" name="Content Placeholder 2"/>
-          <p:cNvSpPr>
-            <a:spLocks noGrp="1"/>
-          </p:cNvSpPr>
-          <p:nvPr>
-            <p:ph idx="1"/>
-          </p:nvPr>
-        </p:nvSpPr>
-        <p:spPr/>
-        <p:txBody>
-          <a:bodyPr/>
-          <a:lstStyle/>
-          <a:p>
-            <a:pPr>
-              <a:spcAft>
-                <a:spcPts val="1000"/>
-              </a:spcAft>
-              <a:defRPr sz="2200"/>
-            </a:pPr>
-            <a:r>
-              <a:t>README.md</a:t>
-            </a:r>
-          </a:p>
-          <a:p>
-            <a:pPr>
-              <a:spcAft>
-                <a:spcPts val="1000"/>
-              </a:spcAft>
-              <a:defRPr sz="2200"/>
-            </a:pPr>
-            <a:r>
-              <a:t>Final_Report.pdf</a:t>
-            </a:r>
-          </a:p>
-          <a:p>
-            <a:pPr>
-              <a:spcAft>
-                <a:spcPts val="1000"/>
-              </a:spcAft>
-              <a:defRPr sz="2200"/>
-            </a:pPr>
-            <a:r>
-              <a:t>Presentation.pptx</a:t>
-            </a:r>
-          </a:p>
-          <a:p>
-            <a:pPr>
-              <a:spcAft>
-                <a:spcPts val="1000"/>
-              </a:spcAft>
-              <a:defRPr sz="2200"/>
-            </a:pPr>
-            <a:r>
-              <a:t>bluestock_mf.pbix</a:t>
-            </a:r>
-          </a:p>
-          <a:p>
-            <a:pPr>
-              <a:spcAft>
-                <a:spcPts val="1000"/>
-              </a:spcAft>
-              <a:defRPr sz="2200"/>
-            </a:pPr>
-            <a:r>
-              <a:t>Python notebooks, scripts and SQL files</a:t>
+          <a:p/>
+        </p:txBody>
+      </p:sp>
+      <p:sp>
+        <p:nvSpPr>
+          <p:cNvPr id="3" name="TextBox 2"/>
+          <p:cNvSpPr txBox="1"/>
+          <p:nvPr/>
+        </p:nvSpPr>
+        <p:spPr>
+          <a:xfrm>
+            <a:off x="640080" y="411480"/>
+            <a:ext cx="10881360" cy="640080"/>
+          </a:xfrm>
+          <a:prstGeom prst="rect">
+            <a:avLst/>
+          </a:prstGeom>
+          <a:noFill/>
+        </p:spPr>
+        <p:txBody>
+          <a:bodyPr wrap="none">
+            <a:spAutoFit/>
+          </a:bodyPr>
+          <a:lstStyle/>
+          <a:p>
+            <a:pPr>
+              <a:defRPr sz="3000" b="1"/>
+            </a:pPr>
+            <a:r>
+              <a:t>Dashboard — Executive &amp; Performance</a:t>
+            </a:r>
+          </a:p>
+        </p:txBody>
+      </p:sp>
+      <p:sp>
+        <p:nvSpPr>
+          <p:cNvPr id="4" name="TextBox 3"/>
+          <p:cNvSpPr txBox="1"/>
+          <p:nvPr/>
+        </p:nvSpPr>
+        <p:spPr>
+          <a:xfrm>
+            <a:off x="822960" y="1234440"/>
+            <a:ext cx="10515600" cy="5029200"/>
+          </a:xfrm>
+          <a:prstGeom prst="rect">
+            <a:avLst/>
+          </a:prstGeom>
+          <a:noFill/>
+        </p:spPr>
+        <p:txBody>
+          <a:bodyPr wrap="square">
+            <a:spAutoFit/>
+          </a:bodyPr>
+          <a:lstStyle/>
+          <a:p>
+            <a:pPr>
+              <a:spcAft>
+                <a:spcPts val="1200"/>
+              </a:spcAft>
+              <a:defRPr sz="2100"/>
+            </a:pPr>
+            <a:r>
+              <a:t>Page 1: Executive Overview</a:t>
+            </a:r>
+          </a:p>
+          <a:p>
+            <a:pPr>
+              <a:spcAft>
+                <a:spcPts val="1200"/>
+              </a:spcAft>
+              <a:defRPr sz="2100"/>
+            </a:pPr>
+            <a:r>
+              <a:t>Page 2: Fund Performance &amp; Risk</a:t>
+            </a:r>
+          </a:p>
+          <a:p>
+            <a:pPr>
+              <a:spcAft>
+                <a:spcPts val="1200"/>
+              </a:spcAft>
+              <a:defRPr sz="2100"/>
+            </a:pPr>
+            <a:r>
+              <a:t>Interactive slicers support filtering by relevant fund dimensions.</a:t>
+            </a:r>
+          </a:p>
+          <a:p>
+            <a:pPr>
+              <a:spcAft>
+                <a:spcPts val="1200"/>
+              </a:spcAft>
+              <a:defRPr sz="2100"/>
+            </a:pPr>
+            <a:r>
+              <a:t>Views combine summary indicators, returns, risk and AUM.</a:t>
             </a:r>
           </a:p>
         </p:txBody>

</xml_diff>